<commit_message>
Set prices + swap Alkaline→Bonaqua in sets
- Set 1 600,000₮, Set 2 900,000₮, Set 3 1,200,000₮, Set 4 500,000₮
- Replace all "Alkaline ус" with "Bonaqua ус" in the sets (live menu)
- Remove "pricing coming soon" note
- Regenerate print/C-Garden-Sets-halfA4.pptx with totals + Bonaqua
- Bump assets to v=11

Co-Authored-By: Claude Opus 4.8 <noreply@anthropic.com>
Claude-Session: https://claude.ai/code/session_01TnVy1C21x68ctXsvvdvyLV
</commit_message>
<xml_diff>
--- a/print/C-Garden-Sets-halfA4.pptx
+++ b/print/C-Garden-Sets-halfA4.pptx
@@ -3148,7 +3148,7 @@
         </p:blipFill>
         <p:spPr>
           <a:xfrm>
-            <a:off x="3095244" y="164592"/>
+            <a:off x="3095244" y="146304"/>
             <a:ext cx="1371600" cy="1143000"/>
           </a:xfrm>
           <a:prstGeom prst="rect">
@@ -3164,8 +3164,8 @@
         </p:nvSpPr>
         <p:spPr>
           <a:xfrm>
-            <a:off x="0" y="1207008"/>
-            <a:ext cx="7562088" cy="320040"/>
+            <a:off x="0" y="1188720"/>
+            <a:ext cx="7562088" cy="292608"/>
           </a:xfrm>
           <a:prstGeom prst="rect">
             <a:avLst/>
@@ -3199,8 +3199,8 @@
         </p:nvSpPr>
         <p:spPr>
           <a:xfrm>
-            <a:off x="411480" y="1691640"/>
-            <a:ext cx="1602485" cy="3474720"/>
+            <a:off x="411480" y="1600200"/>
+            <a:ext cx="1602485" cy="3611880"/>
           </a:xfrm>
           <a:prstGeom prst="rect">
             <a:avLst/>
@@ -3215,17 +3215,33 @@
           <a:p>
             <a:pPr>
               <a:spcAft>
+                <a:spcPts val="100"/>
+              </a:spcAft>
+            </a:pPr>
+            <a:r>
+              <a:rPr sz="1300" b="1">
+                <a:solidFill>
+                  <a:srgbClr val="1B5E20"/>
+                </a:solidFill>
+                <a:latin typeface="Georgia"/>
+              </a:rPr>
+              <a:t>Сэт 1</a:t>
+            </a:r>
+          </a:p>
+          <a:p>
+            <a:pPr>
+              <a:spcAft>
                 <a:spcPts val="300"/>
               </a:spcAft>
             </a:pPr>
             <a:r>
-              <a:rPr sz="1300" b="1">
-                <a:solidFill>
-                  <a:srgbClr val="1B5E20"/>
+              <a:rPr sz="1200" b="1">
+                <a:solidFill>
+                  <a:srgbClr val="9C7A2E"/>
                 </a:solidFill>
                 <a:latin typeface="Georgia"/>
               </a:rPr>
-              <a:t>Сэт 1</a:t>
+              <a:t>600,000₮</a:t>
             </a:r>
           </a:p>
           <a:p>
@@ -3300,7 +3316,7 @@
                 </a:solidFill>
                 <a:latin typeface="Arial"/>
               </a:rPr>
-              <a:t>Alkaline ус</a:t>
+              <a:t>Bonaqua ус</a:t>
             </a:r>
             <a:r>
               <a:rPr sz="950" b="1">
@@ -3384,8 +3400,8 @@
         </p:nvSpPr>
         <p:spPr>
           <a:xfrm>
-            <a:off x="2123694" y="1691640"/>
-            <a:ext cx="1602485" cy="3474720"/>
+            <a:off x="2123694" y="1600200"/>
+            <a:ext cx="1602485" cy="3611880"/>
           </a:xfrm>
           <a:prstGeom prst="rect">
             <a:avLst/>
@@ -3400,17 +3416,33 @@
           <a:p>
             <a:pPr>
               <a:spcAft>
+                <a:spcPts val="100"/>
+              </a:spcAft>
+            </a:pPr>
+            <a:r>
+              <a:rPr sz="1300" b="1">
+                <a:solidFill>
+                  <a:srgbClr val="1B5E20"/>
+                </a:solidFill>
+                <a:latin typeface="Georgia"/>
+              </a:rPr>
+              <a:t>Сэт 2</a:t>
+            </a:r>
+          </a:p>
+          <a:p>
+            <a:pPr>
+              <a:spcAft>
                 <a:spcPts val="300"/>
               </a:spcAft>
             </a:pPr>
             <a:r>
-              <a:rPr sz="1300" b="1">
-                <a:solidFill>
-                  <a:srgbClr val="1B5E20"/>
+              <a:rPr sz="1200" b="1">
+                <a:solidFill>
+                  <a:srgbClr val="9C7A2E"/>
                 </a:solidFill>
                 <a:latin typeface="Georgia"/>
               </a:rPr>
-              <a:t>Сэт 2</a:t>
+              <a:t>900,000₮</a:t>
             </a:r>
           </a:p>
           <a:p>
@@ -3494,7 +3526,7 @@
                 </a:solidFill>
                 <a:latin typeface="Arial"/>
               </a:rPr>
-              <a:t>Alkaline ус</a:t>
+              <a:t>Bonaqua ус</a:t>
             </a:r>
             <a:r>
               <a:rPr sz="950" b="1">
@@ -3578,8 +3610,8 @@
         </p:nvSpPr>
         <p:spPr>
           <a:xfrm>
-            <a:off x="3835907" y="1691640"/>
-            <a:ext cx="1602485" cy="3474720"/>
+            <a:off x="3835907" y="1600200"/>
+            <a:ext cx="1602485" cy="3611880"/>
           </a:xfrm>
           <a:prstGeom prst="rect">
             <a:avLst/>
@@ -3594,17 +3626,33 @@
           <a:p>
             <a:pPr>
               <a:spcAft>
+                <a:spcPts val="100"/>
+              </a:spcAft>
+            </a:pPr>
+            <a:r>
+              <a:rPr sz="1300" b="1">
+                <a:solidFill>
+                  <a:srgbClr val="1B5E20"/>
+                </a:solidFill>
+                <a:latin typeface="Georgia"/>
+              </a:rPr>
+              <a:t>Сэт 3</a:t>
+            </a:r>
+          </a:p>
+          <a:p>
+            <a:pPr>
+              <a:spcAft>
                 <a:spcPts val="300"/>
               </a:spcAft>
             </a:pPr>
             <a:r>
-              <a:rPr sz="1300" b="1">
-                <a:solidFill>
-                  <a:srgbClr val="1B5E20"/>
+              <a:rPr sz="1200" b="1">
+                <a:solidFill>
+                  <a:srgbClr val="9C7A2E"/>
                 </a:solidFill>
                 <a:latin typeface="Georgia"/>
               </a:rPr>
-              <a:t>Сэт 3</a:t>
+              <a:t>1,200,000₮</a:t>
             </a:r>
           </a:p>
           <a:p>
@@ -3710,7 +3758,7 @@
                 </a:solidFill>
                 <a:latin typeface="Arial"/>
               </a:rPr>
-              <a:t>Alkaline ус</a:t>
+              <a:t>Bonaqua ус</a:t>
             </a:r>
             <a:r>
               <a:rPr sz="950" b="1">
@@ -3825,8 +3873,8 @@
         </p:nvSpPr>
         <p:spPr>
           <a:xfrm>
-            <a:off x="5548121" y="1691640"/>
-            <a:ext cx="1602485" cy="3474720"/>
+            <a:off x="5548121" y="1600200"/>
+            <a:ext cx="1602485" cy="3611880"/>
           </a:xfrm>
           <a:prstGeom prst="rect">
             <a:avLst/>
@@ -3841,7 +3889,7 @@
           <a:p>
             <a:pPr>
               <a:spcAft>
-                <a:spcPts val="300"/>
+                <a:spcPts val="100"/>
               </a:spcAft>
             </a:pPr>
             <a:r>
@@ -3861,13 +3909,22 @@
               </a:spcAft>
             </a:pPr>
             <a:r>
-              <a:rPr sz="800" b="1">
+              <a:rPr sz="1200" b="1">
                 <a:solidFill>
                   <a:srgbClr val="9C7A2E"/>
                 </a:solidFill>
-                <a:latin typeface="Arial"/>
-              </a:rPr>
-              <a:t>4 ХҮН</a:t>
+                <a:latin typeface="Georgia"/>
+              </a:rPr>
+              <a:t>500,000₮</a:t>
+            </a:r>
+            <a:r>
+              <a:rPr sz="800">
+                <a:solidFill>
+                  <a:srgbClr val="778078"/>
+                </a:solidFill>
+                <a:latin typeface="Arial"/>
+              </a:rPr>
+              <a:t>   4 хүн</a:t>
             </a:r>
           </a:p>
           <a:p>
@@ -3951,7 +4008,7 @@
                 </a:solidFill>
                 <a:latin typeface="Arial"/>
               </a:rPr>
-              <a:t>Alkaline ус</a:t>
+              <a:t>Bonaqua ус</a:t>
             </a:r>
             <a:r>
               <a:rPr sz="950" b="1">

</xml_diff>

<commit_message>
Set menu PPTX: retitle to "Today's Special Set Menu", keep logo
Replace the "СЭТ ЦЭС" heading with "Today's Special Set Menu" (the C Garden
logo remains above it).

Co-Authored-By: Claude Opus 4.8 <noreply@anthropic.com>
Claude-Session: https://claude.ai/code/session_01TnVy1C21x68ctXsvvdvyLV
</commit_message>
<xml_diff>
--- a/print/C-Garden-Sets-halfA4.pptx
+++ b/print/C-Garden-Sets-halfA4.pptx
@@ -3165,7 +3165,7 @@
         <p:spPr>
           <a:xfrm>
             <a:off x="0" y="1188720"/>
-            <a:ext cx="7562088" cy="292608"/>
+            <a:ext cx="7562088" cy="365760"/>
           </a:xfrm>
           <a:prstGeom prst="rect">
             <a:avLst/>
@@ -3180,13 +3180,13 @@
           <a:p>
             <a:pPr algn="ctr"/>
             <a:r>
-              <a:rPr sz="1100" b="1">
-                <a:solidFill>
-                  <a:srgbClr val="9C7A2E"/>
-                </a:solidFill>
-                <a:latin typeface="Arial"/>
-              </a:rPr>
-              <a:t>С Э Т   Ц Э С</a:t>
+              <a:rPr sz="1500" i="1" b="1">
+                <a:solidFill>
+                  <a:srgbClr val="1B5E20"/>
+                </a:solidFill>
+                <a:latin typeface="Georgia"/>
+              </a:rPr>
+              <a:t>Today’s Special Set Menu</a:t>
             </a:r>
           </a:p>
         </p:txBody>
@@ -3199,8 +3199,8 @@
         </p:nvSpPr>
         <p:spPr>
           <a:xfrm>
-            <a:off x="411480" y="1600200"/>
-            <a:ext cx="1602485" cy="3611880"/>
+            <a:off x="411480" y="1737360"/>
+            <a:ext cx="1602485" cy="3520440"/>
           </a:xfrm>
           <a:prstGeom prst="rect">
             <a:avLst/>
@@ -3400,8 +3400,8 @@
         </p:nvSpPr>
         <p:spPr>
           <a:xfrm>
-            <a:off x="2123694" y="1600200"/>
-            <a:ext cx="1602485" cy="3611880"/>
+            <a:off x="2123694" y="1737360"/>
+            <a:ext cx="1602485" cy="3520440"/>
           </a:xfrm>
           <a:prstGeom prst="rect">
             <a:avLst/>
@@ -3610,8 +3610,8 @@
         </p:nvSpPr>
         <p:spPr>
           <a:xfrm>
-            <a:off x="3835907" y="1600200"/>
-            <a:ext cx="1602485" cy="3611880"/>
+            <a:off x="3835907" y="1737360"/>
+            <a:ext cx="1602485" cy="3520440"/>
           </a:xfrm>
           <a:prstGeom prst="rect">
             <a:avLst/>
@@ -3873,8 +3873,8 @@
         </p:nvSpPr>
         <p:spPr>
           <a:xfrm>
-            <a:off x="5548121" y="1600200"/>
-            <a:ext cx="1602485" cy="3611880"/>
+            <a:off x="5548121" y="1737360"/>
+            <a:ext cx="1602485" cy="3520440"/>
           </a:xfrm>
           <a:prstGeom prst="rect">
             <a:avLst/>

</xml_diff>